<commit_message>
updated slides and slight mods to pbix before final go
</commit_message>
<xml_diff>
--- a/2026.06.12 BI Days/2026.06.12 BI Days PPT.pptx
+++ b/2026.06.12 BI Days/2026.06.12 BI Days PPT.pptx
@@ -4373,12 +4373,72 @@
       <dgm:prSet presAssocID="{EC571630-960C-4F39-9324-566494290F15}" presName="sibTrans" presStyleCnt="0"/>
       <dgm:spPr/>
     </dgm:pt>
+    <dgm:pt modelId="{D78A3DBB-82E5-490C-B301-0D08000AC7A3}" type="pres">
+      <dgm:prSet presAssocID="{A59E1F80-2579-405C-8E1B-E755366AC1CA}" presName="compNode" presStyleCnt="0"/>
+      <dgm:spPr/>
+    </dgm:pt>
+    <dgm:pt modelId="{7CE07CC9-08F1-4CF6-BE07-714FC2703C80}" type="pres">
+      <dgm:prSet presAssocID="{A59E1F80-2579-405C-8E1B-E755366AC1CA}" presName="iconBgRect" presStyleLbl="bgShp" presStyleIdx="2" presStyleCnt="5"/>
+      <dgm:spPr>
+        <a:prstGeom prst="round2DiagRect">
+          <a:avLst>
+            <a:gd name="adj1" fmla="val 29727"/>
+            <a:gd name="adj2" fmla="val 0"/>
+          </a:avLst>
+        </a:prstGeom>
+      </dgm:spPr>
+    </dgm:pt>
+    <dgm:pt modelId="{703D2A3C-1CDD-46B0-8269-0384BEACC37F}" type="pres">
+      <dgm:prSet presAssocID="{A59E1F80-2579-405C-8E1B-E755366AC1CA}" presName="iconRect" presStyleLbl="node1" presStyleIdx="2" presStyleCnt="5"/>
+      <dgm:spPr>
+        <a:blipFill>
+          <a:blip xmlns:r="http://schemas.openxmlformats.org/officeDocument/2006/relationships">
+            <a:extLst>
+              <a:ext uri="{28A0092B-C50C-407E-A947-70E740481C1C}">
+                <a14:useLocalDpi xmlns:a14="http://schemas.microsoft.com/office/drawing/2010/main" val="0"/>
+              </a:ext>
+              <a:ext uri="{96DAC541-7B7A-43D3-8B79-37D633B846F1}">
+                <asvg:svgBlip xmlns:asvg="http://schemas.microsoft.com/office/drawing/2016/SVG/main" r:embed="rId3"/>
+              </a:ext>
+            </a:extLst>
+          </a:blip>
+          <a:stretch>
+            <a:fillRect/>
+          </a:stretch>
+        </a:blipFill>
+        <a:ln>
+          <a:noFill/>
+        </a:ln>
+      </dgm:spPr>
+      <dgm:extLst>
+        <a:ext uri="{E40237B7-FDA0-4F09-8148-C483321AD2D9}">
+          <dgm14:cNvPr xmlns:dgm14="http://schemas.microsoft.com/office/drawing/2010/diagram" id="0" name="" descr="Magnifying glass"/>
+        </a:ext>
+      </dgm:extLst>
+    </dgm:pt>
+    <dgm:pt modelId="{603CB7F2-C4DB-4E4E-B86C-6F1C40BDC9E8}" type="pres">
+      <dgm:prSet presAssocID="{A59E1F80-2579-405C-8E1B-E755366AC1CA}" presName="spaceRect" presStyleCnt="0"/>
+      <dgm:spPr/>
+    </dgm:pt>
+    <dgm:pt modelId="{A2E01365-6E26-40CE-80C4-551C1E26459E}" type="pres">
+      <dgm:prSet presAssocID="{A59E1F80-2579-405C-8E1B-E755366AC1CA}" presName="textRect" presStyleLbl="revTx" presStyleIdx="2" presStyleCnt="5">
+        <dgm:presLayoutVars>
+          <dgm:chMax val="1"/>
+          <dgm:chPref val="1"/>
+        </dgm:presLayoutVars>
+      </dgm:prSet>
+      <dgm:spPr/>
+    </dgm:pt>
+    <dgm:pt modelId="{A6050820-2AE8-4C1E-8B45-06C1F9A7A36F}" type="pres">
+      <dgm:prSet presAssocID="{63BB04FF-92C6-4AD3-A14C-D3BA63807C8B}" presName="sibTrans" presStyleCnt="0"/>
+      <dgm:spPr/>
+    </dgm:pt>
     <dgm:pt modelId="{FC8EC8C0-E71B-464F-922E-C5B89B1A8231}" type="pres">
       <dgm:prSet presAssocID="{C2760C52-BA17-481B-B990-64CA39382A85}" presName="compNode" presStyleCnt="0"/>
       <dgm:spPr/>
     </dgm:pt>
     <dgm:pt modelId="{93511C22-D1BE-4E6A-A774-854639220357}" type="pres">
-      <dgm:prSet presAssocID="{C2760C52-BA17-481B-B990-64CA39382A85}" presName="iconBgRect" presStyleLbl="bgShp" presStyleIdx="2" presStyleCnt="5"/>
+      <dgm:prSet presAssocID="{C2760C52-BA17-481B-B990-64CA39382A85}" presName="iconBgRect" presStyleLbl="bgShp" presStyleIdx="3" presStyleCnt="5"/>
       <dgm:spPr>
         <a:prstGeom prst="round2DiagRect">
           <a:avLst>
@@ -4389,7 +4449,7 @@
       </dgm:spPr>
     </dgm:pt>
     <dgm:pt modelId="{E7C25ED2-8DE3-491B-9855-23F6F91ECE47}" type="pres">
-      <dgm:prSet presAssocID="{C2760C52-BA17-481B-B990-64CA39382A85}" presName="iconRect" presStyleLbl="node1" presStyleIdx="2" presStyleCnt="5"/>
+      <dgm:prSet presAssocID="{C2760C52-BA17-481B-B990-64CA39382A85}" presName="iconRect" presStyleLbl="node1" presStyleIdx="3" presStyleCnt="5"/>
       <dgm:spPr>
         <a:blipFill>
           <a:blip xmlns:r="http://schemas.openxmlformats.org/officeDocument/2006/relationships">
@@ -4398,7 +4458,7 @@
                 <a14:useLocalDpi xmlns:a14="http://schemas.microsoft.com/office/drawing/2010/main" val="0"/>
               </a:ext>
               <a:ext uri="{96DAC541-7B7A-43D3-8B79-37D633B846F1}">
-                <asvg:svgBlip xmlns:asvg="http://schemas.microsoft.com/office/drawing/2016/SVG/main" r:embed="rId3"/>
+                <asvg:svgBlip xmlns:asvg="http://schemas.microsoft.com/office/drawing/2016/SVG/main" r:embed="rId4"/>
               </a:ext>
             </a:extLst>
           </a:blip>
@@ -4421,7 +4481,7 @@
       <dgm:spPr/>
     </dgm:pt>
     <dgm:pt modelId="{416B4E3C-E3B1-40FD-99B5-8458F3238C8A}" type="pres">
-      <dgm:prSet presAssocID="{C2760C52-BA17-481B-B990-64CA39382A85}" presName="textRect" presStyleLbl="revTx" presStyleIdx="2" presStyleCnt="5">
+      <dgm:prSet presAssocID="{C2760C52-BA17-481B-B990-64CA39382A85}" presName="textRect" presStyleLbl="revTx" presStyleIdx="3" presStyleCnt="5">
         <dgm:presLayoutVars>
           <dgm:chMax val="1"/>
           <dgm:chPref val="1"/>
@@ -4431,66 +4491,6 @@
     </dgm:pt>
     <dgm:pt modelId="{6FE06377-0D57-45A7-B6CD-8A7DD547A58E}" type="pres">
       <dgm:prSet presAssocID="{8614DB98-61B4-4059-9EB1-AA88059C3409}" presName="sibTrans" presStyleCnt="0"/>
-      <dgm:spPr/>
-    </dgm:pt>
-    <dgm:pt modelId="{D78A3DBB-82E5-490C-B301-0D08000AC7A3}" type="pres">
-      <dgm:prSet presAssocID="{A59E1F80-2579-405C-8E1B-E755366AC1CA}" presName="compNode" presStyleCnt="0"/>
-      <dgm:spPr/>
-    </dgm:pt>
-    <dgm:pt modelId="{7CE07CC9-08F1-4CF6-BE07-714FC2703C80}" type="pres">
-      <dgm:prSet presAssocID="{A59E1F80-2579-405C-8E1B-E755366AC1CA}" presName="iconBgRect" presStyleLbl="bgShp" presStyleIdx="3" presStyleCnt="5"/>
-      <dgm:spPr>
-        <a:prstGeom prst="round2DiagRect">
-          <a:avLst>
-            <a:gd name="adj1" fmla="val 29727"/>
-            <a:gd name="adj2" fmla="val 0"/>
-          </a:avLst>
-        </a:prstGeom>
-      </dgm:spPr>
-    </dgm:pt>
-    <dgm:pt modelId="{703D2A3C-1CDD-46B0-8269-0384BEACC37F}" type="pres">
-      <dgm:prSet presAssocID="{A59E1F80-2579-405C-8E1B-E755366AC1CA}" presName="iconRect" presStyleLbl="node1" presStyleIdx="3" presStyleCnt="5"/>
-      <dgm:spPr>
-        <a:blipFill>
-          <a:blip xmlns:r="http://schemas.openxmlformats.org/officeDocument/2006/relationships">
-            <a:extLst>
-              <a:ext uri="{28A0092B-C50C-407E-A947-70E740481C1C}">
-                <a14:useLocalDpi xmlns:a14="http://schemas.microsoft.com/office/drawing/2010/main" val="0"/>
-              </a:ext>
-              <a:ext uri="{96DAC541-7B7A-43D3-8B79-37D633B846F1}">
-                <asvg:svgBlip xmlns:asvg="http://schemas.microsoft.com/office/drawing/2016/SVG/main" r:embed="rId4"/>
-              </a:ext>
-            </a:extLst>
-          </a:blip>
-          <a:stretch>
-            <a:fillRect/>
-          </a:stretch>
-        </a:blipFill>
-        <a:ln>
-          <a:noFill/>
-        </a:ln>
-      </dgm:spPr>
-      <dgm:extLst>
-        <a:ext uri="{E40237B7-FDA0-4F09-8148-C483321AD2D9}">
-          <dgm14:cNvPr xmlns:dgm14="http://schemas.microsoft.com/office/drawing/2010/diagram" id="0" name="" descr="Magnifying glass"/>
-        </a:ext>
-      </dgm:extLst>
-    </dgm:pt>
-    <dgm:pt modelId="{603CB7F2-C4DB-4E4E-B86C-6F1C40BDC9E8}" type="pres">
-      <dgm:prSet presAssocID="{A59E1F80-2579-405C-8E1B-E755366AC1CA}" presName="spaceRect" presStyleCnt="0"/>
-      <dgm:spPr/>
-    </dgm:pt>
-    <dgm:pt modelId="{A2E01365-6E26-40CE-80C4-551C1E26459E}" type="pres">
-      <dgm:prSet presAssocID="{A59E1F80-2579-405C-8E1B-E755366AC1CA}" presName="textRect" presStyleLbl="revTx" presStyleIdx="3" presStyleCnt="5">
-        <dgm:presLayoutVars>
-          <dgm:chMax val="1"/>
-          <dgm:chPref val="1"/>
-        </dgm:presLayoutVars>
-      </dgm:prSet>
-      <dgm:spPr/>
-    </dgm:pt>
-    <dgm:pt modelId="{A6050820-2AE8-4C1E-8B45-06C1F9A7A36F}" type="pres">
-      <dgm:prSet presAssocID="{63BB04FF-92C6-4AD3-A14C-D3BA63807C8B}" presName="sibTrans" presStyleCnt="0"/>
       <dgm:spPr/>
     </dgm:pt>
     <dgm:pt modelId="{3A3C9431-5B72-4FD3-9B99-9774F8C7BA6C}" type="pres">
@@ -4551,46 +4551,46 @@
     </dgm:pt>
   </dgm:ptLst>
   <dgm:cxnLst>
-    <dgm:cxn modelId="{3339F501-8CCD-40AA-80D7-A3660CA9142B}" type="presOf" srcId="{D3A90378-A1E5-40B8-AF59-7238D192FF39}" destId="{4B691EFD-B269-4CA7-932D-6797DB9C8247}" srcOrd="0" destOrd="0" presId="urn:microsoft.com/office/officeart/2018/5/layout/IconLeafLabelList"/>
-    <dgm:cxn modelId="{6F2AB645-2175-49D0-A3CB-7AD5B594D500}" type="presOf" srcId="{C2760C52-BA17-481B-B990-64CA39382A85}" destId="{416B4E3C-E3B1-40FD-99B5-8458F3238C8A}" srcOrd="0" destOrd="0" presId="urn:microsoft.com/office/officeart/2018/5/layout/IconLeafLabelList"/>
+    <dgm:cxn modelId="{5554FB63-4026-4F84-AC60-309FF523CCFB}" type="presOf" srcId="{D3A90378-A1E5-40B8-AF59-7238D192FF39}" destId="{4B691EFD-B269-4CA7-932D-6797DB9C8247}" srcOrd="0" destOrd="0" presId="urn:microsoft.com/office/officeart/2018/5/layout/IconLeafLabelList"/>
     <dgm:cxn modelId="{4F3C1D49-24DA-4D49-972E-A515886AC453}" type="presOf" srcId="{BFA6A4E2-912C-4591-BB4E-F95CA3857702}" destId="{FB41830B-D528-4EF1-992C-56941B20706C}" srcOrd="0" destOrd="0" presId="urn:microsoft.com/office/officeart/2018/5/layout/IconLeafLabelList"/>
-    <dgm:cxn modelId="{A0053F75-D157-4322-BA48-26CBB242691A}" type="presOf" srcId="{A59E1F80-2579-405C-8E1B-E755366AC1CA}" destId="{A2E01365-6E26-40CE-80C4-551C1E26459E}" srcOrd="0" destOrd="0" presId="urn:microsoft.com/office/officeart/2018/5/layout/IconLeafLabelList"/>
-    <dgm:cxn modelId="{DE84A577-9AE4-43C6-AA75-A0B399186430}" srcId="{BFA6A4E2-912C-4591-BB4E-F95CA3857702}" destId="{A59E1F80-2579-405C-8E1B-E755366AC1CA}" srcOrd="3" destOrd="0" parTransId="{0E779545-6791-402C-910E-C1B396B387F9}" sibTransId="{63BB04FF-92C6-4AD3-A14C-D3BA63807C8B}"/>
-    <dgm:cxn modelId="{58F72C7D-D848-4E68-9CAD-F85F964ECC7A}" type="presOf" srcId="{DD844099-09D9-4176-9D09-04DC8634D869}" destId="{D8ADCAA9-FC51-4EF4-9FF7-67F32462255F}" srcOrd="0" destOrd="0" presId="urn:microsoft.com/office/officeart/2018/5/layout/IconLeafLabelList"/>
-    <dgm:cxn modelId="{325F3290-FEA1-4F3A-B49C-E6CD86795E03}" type="presOf" srcId="{1D88291D-2066-41AA-83F2-C95E9A97D00A}" destId="{7EE269EF-7E38-4A21-98A9-338507085687}" srcOrd="0" destOrd="0" presId="urn:microsoft.com/office/officeart/2018/5/layout/IconLeafLabelList"/>
+    <dgm:cxn modelId="{DE84A577-9AE4-43C6-AA75-A0B399186430}" srcId="{BFA6A4E2-912C-4591-BB4E-F95CA3857702}" destId="{A59E1F80-2579-405C-8E1B-E755366AC1CA}" srcOrd="2" destOrd="0" parTransId="{0E779545-6791-402C-910E-C1B396B387F9}" sibTransId="{63BB04FF-92C6-4AD3-A14C-D3BA63807C8B}"/>
     <dgm:cxn modelId="{230BAC92-31FC-498E-97DF-D97883E83D53}" srcId="{BFA6A4E2-912C-4591-BB4E-F95CA3857702}" destId="{DD844099-09D9-4176-9D09-04DC8634D869}" srcOrd="1" destOrd="0" parTransId="{F068B28B-CE8F-4A46-A7AE-1F7838100E3C}" sibTransId="{EC571630-960C-4F39-9324-566494290F15}"/>
     <dgm:cxn modelId="{4E2CDC95-D5EE-4DA0-9D0E-4772F2D9BB37}" srcId="{BFA6A4E2-912C-4591-BB4E-F95CA3857702}" destId="{D3A90378-A1E5-40B8-AF59-7238D192FF39}" srcOrd="0" destOrd="0" parTransId="{90C99A7A-82F0-40A4-B517-385E2F6ABA77}" sibTransId="{6E59B61C-BED4-48D9-97D5-DD1C0526A682}"/>
-    <dgm:cxn modelId="{B57E04AA-4EB0-48E9-B1E2-E360102AEC80}" srcId="{BFA6A4E2-912C-4591-BB4E-F95CA3857702}" destId="{C2760C52-BA17-481B-B990-64CA39382A85}" srcOrd="2" destOrd="0" parTransId="{953FDAD6-1243-47A2-8FCD-30F8326D9707}" sibTransId="{8614DB98-61B4-4059-9EB1-AA88059C3409}"/>
+    <dgm:cxn modelId="{B57E04AA-4EB0-48E9-B1E2-E360102AEC80}" srcId="{BFA6A4E2-912C-4591-BB4E-F95CA3857702}" destId="{C2760C52-BA17-481B-B990-64CA39382A85}" srcOrd="3" destOrd="0" parTransId="{953FDAD6-1243-47A2-8FCD-30F8326D9707}" sibTransId="{8614DB98-61B4-4059-9EB1-AA88059C3409}"/>
+    <dgm:cxn modelId="{3750EDB8-D291-49FE-85AB-9BC11122D2E1}" type="presOf" srcId="{A59E1F80-2579-405C-8E1B-E755366AC1CA}" destId="{A2E01365-6E26-40CE-80C4-551C1E26459E}" srcOrd="0" destOrd="0" presId="urn:microsoft.com/office/officeart/2018/5/layout/IconLeafLabelList"/>
+    <dgm:cxn modelId="{3D6743B9-1833-42C2-8264-370A8D6D73EA}" type="presOf" srcId="{C2760C52-BA17-481B-B990-64CA39382A85}" destId="{416B4E3C-E3B1-40FD-99B5-8458F3238C8A}" srcOrd="0" destOrd="0" presId="urn:microsoft.com/office/officeart/2018/5/layout/IconLeafLabelList"/>
     <dgm:cxn modelId="{7050DADE-2397-4F0E-8163-6E5FF2CA25B4}" srcId="{BFA6A4E2-912C-4591-BB4E-F95CA3857702}" destId="{1D88291D-2066-41AA-83F2-C95E9A97D00A}" srcOrd="4" destOrd="0" parTransId="{05041D50-A712-4684-BC7B-05462493B2A0}" sibTransId="{E38640AB-D783-4DB0-B6A9-9AA6DA809296}"/>
-    <dgm:cxn modelId="{81F670D7-F6B9-45CC-9F87-177B8F2AAE8A}" type="presParOf" srcId="{FB41830B-D528-4EF1-992C-56941B20706C}" destId="{61A486D0-BD1D-43C9-8C0D-32381BAC4B0D}" srcOrd="0" destOrd="0" presId="urn:microsoft.com/office/officeart/2018/5/layout/IconLeafLabelList"/>
-    <dgm:cxn modelId="{B9B46D3E-D150-4086-AB02-1916F01AED32}" type="presParOf" srcId="{61A486D0-BD1D-43C9-8C0D-32381BAC4B0D}" destId="{A366D388-5187-4B83-91E0-6E344AB43643}" srcOrd="0" destOrd="0" presId="urn:microsoft.com/office/officeart/2018/5/layout/IconLeafLabelList"/>
-    <dgm:cxn modelId="{0FF7FD2A-A0B6-4841-87E2-4EEE9FBBE4C7}" type="presParOf" srcId="{61A486D0-BD1D-43C9-8C0D-32381BAC4B0D}" destId="{A51A27D5-074B-4463-AA5F-C91BAD0101FC}" srcOrd="1" destOrd="0" presId="urn:microsoft.com/office/officeart/2018/5/layout/IconLeafLabelList"/>
-    <dgm:cxn modelId="{D2A3DD2A-55CF-43AA-968C-2C6396C05099}" type="presParOf" srcId="{61A486D0-BD1D-43C9-8C0D-32381BAC4B0D}" destId="{6B2853A1-4BF8-4E9F-B8E6-6704AEFC8C61}" srcOrd="2" destOrd="0" presId="urn:microsoft.com/office/officeart/2018/5/layout/IconLeafLabelList"/>
-    <dgm:cxn modelId="{32D2759C-76BB-4FE0-A25D-EA05A3780D1D}" type="presParOf" srcId="{61A486D0-BD1D-43C9-8C0D-32381BAC4B0D}" destId="{4B691EFD-B269-4CA7-932D-6797DB9C8247}" srcOrd="3" destOrd="0" presId="urn:microsoft.com/office/officeart/2018/5/layout/IconLeafLabelList"/>
-    <dgm:cxn modelId="{57F54C1E-EC6A-41C7-B8B6-87EFEE5BB48C}" type="presParOf" srcId="{FB41830B-D528-4EF1-992C-56941B20706C}" destId="{56A774B7-9CEF-4AB7-AEA5-3801362948B7}" srcOrd="1" destOrd="0" presId="urn:microsoft.com/office/officeart/2018/5/layout/IconLeafLabelList"/>
-    <dgm:cxn modelId="{A452A841-F28D-4C9C-A5C9-1AB8E137203A}" type="presParOf" srcId="{FB41830B-D528-4EF1-992C-56941B20706C}" destId="{7756E9F3-F9CD-4306-8BE5-744416E437A0}" srcOrd="2" destOrd="0" presId="urn:microsoft.com/office/officeart/2018/5/layout/IconLeafLabelList"/>
-    <dgm:cxn modelId="{56E56959-7D0A-4644-BB18-CF9E09FE1F86}" type="presParOf" srcId="{7756E9F3-F9CD-4306-8BE5-744416E437A0}" destId="{98EA8074-91BA-4F37-8400-281BAC8B85AC}" srcOrd="0" destOrd="0" presId="urn:microsoft.com/office/officeart/2018/5/layout/IconLeafLabelList"/>
-    <dgm:cxn modelId="{22DA4088-B737-4AEC-A4E9-2FE96FC0C96C}" type="presParOf" srcId="{7756E9F3-F9CD-4306-8BE5-744416E437A0}" destId="{BCC39ADA-0AE6-4A74-86AE-7B5DCFA5AF06}" srcOrd="1" destOrd="0" presId="urn:microsoft.com/office/officeart/2018/5/layout/IconLeafLabelList"/>
-    <dgm:cxn modelId="{487ADA13-A245-42B8-895E-44D0A34B143C}" type="presParOf" srcId="{7756E9F3-F9CD-4306-8BE5-744416E437A0}" destId="{D40D94F4-905E-457A-A475-08862384F6D6}" srcOrd="2" destOrd="0" presId="urn:microsoft.com/office/officeart/2018/5/layout/IconLeafLabelList"/>
-    <dgm:cxn modelId="{B7E7DBE7-2C8D-4A05-B242-2E03AD838D0E}" type="presParOf" srcId="{7756E9F3-F9CD-4306-8BE5-744416E437A0}" destId="{D8ADCAA9-FC51-4EF4-9FF7-67F32462255F}" srcOrd="3" destOrd="0" presId="urn:microsoft.com/office/officeart/2018/5/layout/IconLeafLabelList"/>
-    <dgm:cxn modelId="{570A5D55-82E3-43BA-968F-97B789A588D2}" type="presParOf" srcId="{FB41830B-D528-4EF1-992C-56941B20706C}" destId="{3CB78F99-D930-4AE3-9678-60B8C8AEB5FE}" srcOrd="3" destOrd="0" presId="urn:microsoft.com/office/officeart/2018/5/layout/IconLeafLabelList"/>
-    <dgm:cxn modelId="{B27DA007-FB1A-4519-980B-DAB5AA0F1F32}" type="presParOf" srcId="{FB41830B-D528-4EF1-992C-56941B20706C}" destId="{FC8EC8C0-E71B-464F-922E-C5B89B1A8231}" srcOrd="4" destOrd="0" presId="urn:microsoft.com/office/officeart/2018/5/layout/IconLeafLabelList"/>
-    <dgm:cxn modelId="{05E30554-415A-44E5-B7DF-E69C29733FC3}" type="presParOf" srcId="{FC8EC8C0-E71B-464F-922E-C5B89B1A8231}" destId="{93511C22-D1BE-4E6A-A774-854639220357}" srcOrd="0" destOrd="0" presId="urn:microsoft.com/office/officeart/2018/5/layout/IconLeafLabelList"/>
-    <dgm:cxn modelId="{3EDE99BF-53B7-4238-B9D3-1E22C2E49AF1}" type="presParOf" srcId="{FC8EC8C0-E71B-464F-922E-C5B89B1A8231}" destId="{E7C25ED2-8DE3-491B-9855-23F6F91ECE47}" srcOrd="1" destOrd="0" presId="urn:microsoft.com/office/officeart/2018/5/layout/IconLeafLabelList"/>
-    <dgm:cxn modelId="{2F724178-8809-4D8C-928F-084A74368155}" type="presParOf" srcId="{FC8EC8C0-E71B-464F-922E-C5B89B1A8231}" destId="{AE279F2E-8592-4BD7-9CC6-4696C1198298}" srcOrd="2" destOrd="0" presId="urn:microsoft.com/office/officeart/2018/5/layout/IconLeafLabelList"/>
-    <dgm:cxn modelId="{FA93EA1F-8ADE-47EE-A5C9-8AFABA5689B2}" type="presParOf" srcId="{FC8EC8C0-E71B-464F-922E-C5B89B1A8231}" destId="{416B4E3C-E3B1-40FD-99B5-8458F3238C8A}" srcOrd="3" destOrd="0" presId="urn:microsoft.com/office/officeart/2018/5/layout/IconLeafLabelList"/>
-    <dgm:cxn modelId="{2A06C389-8D0E-4265-81CE-AEE575A47F2F}" type="presParOf" srcId="{FB41830B-D528-4EF1-992C-56941B20706C}" destId="{6FE06377-0D57-45A7-B6CD-8A7DD547A58E}" srcOrd="5" destOrd="0" presId="urn:microsoft.com/office/officeart/2018/5/layout/IconLeafLabelList"/>
-    <dgm:cxn modelId="{D303603A-58C3-467E-BCC1-51A127E408BD}" type="presParOf" srcId="{FB41830B-D528-4EF1-992C-56941B20706C}" destId="{D78A3DBB-82E5-490C-B301-0D08000AC7A3}" srcOrd="6" destOrd="0" presId="urn:microsoft.com/office/officeart/2018/5/layout/IconLeafLabelList"/>
-    <dgm:cxn modelId="{990500AB-D9AE-44A5-8B0E-6971F3C84017}" type="presParOf" srcId="{D78A3DBB-82E5-490C-B301-0D08000AC7A3}" destId="{7CE07CC9-08F1-4CF6-BE07-714FC2703C80}" srcOrd="0" destOrd="0" presId="urn:microsoft.com/office/officeart/2018/5/layout/IconLeafLabelList"/>
-    <dgm:cxn modelId="{C367E38E-704E-4F6C-859D-8D6EAD88208C}" type="presParOf" srcId="{D78A3DBB-82E5-490C-B301-0D08000AC7A3}" destId="{703D2A3C-1CDD-46B0-8269-0384BEACC37F}" srcOrd="1" destOrd="0" presId="urn:microsoft.com/office/officeart/2018/5/layout/IconLeafLabelList"/>
-    <dgm:cxn modelId="{A101BA66-DDA8-446F-91A0-E84C4080CABD}" type="presParOf" srcId="{D78A3DBB-82E5-490C-B301-0D08000AC7A3}" destId="{603CB7F2-C4DB-4E4E-B86C-6F1C40BDC9E8}" srcOrd="2" destOrd="0" presId="urn:microsoft.com/office/officeart/2018/5/layout/IconLeafLabelList"/>
-    <dgm:cxn modelId="{63036078-4C77-4E5E-9715-DFFFBA4A379E}" type="presParOf" srcId="{D78A3DBB-82E5-490C-B301-0D08000AC7A3}" destId="{A2E01365-6E26-40CE-80C4-551C1E26459E}" srcOrd="3" destOrd="0" presId="urn:microsoft.com/office/officeart/2018/5/layout/IconLeafLabelList"/>
-    <dgm:cxn modelId="{D24862AE-D72C-4B70-A126-338DBBEB737F}" type="presParOf" srcId="{FB41830B-D528-4EF1-992C-56941B20706C}" destId="{A6050820-2AE8-4C1E-8B45-06C1F9A7A36F}" srcOrd="7" destOrd="0" presId="urn:microsoft.com/office/officeart/2018/5/layout/IconLeafLabelList"/>
-    <dgm:cxn modelId="{F86A7E68-B0D3-4418-AAAF-571B137E442A}" type="presParOf" srcId="{FB41830B-D528-4EF1-992C-56941B20706C}" destId="{3A3C9431-5B72-4FD3-9B99-9774F8C7BA6C}" srcOrd="8" destOrd="0" presId="urn:microsoft.com/office/officeart/2018/5/layout/IconLeafLabelList"/>
-    <dgm:cxn modelId="{09A376AC-1291-4541-8980-4EF8F46A688C}" type="presParOf" srcId="{3A3C9431-5B72-4FD3-9B99-9774F8C7BA6C}" destId="{12F373DD-BC05-4BB2-82BA-547BFC3FF142}" srcOrd="0" destOrd="0" presId="urn:microsoft.com/office/officeart/2018/5/layout/IconLeafLabelList"/>
-    <dgm:cxn modelId="{41DE4390-3FF9-4EE0-889D-86F3620DD3A3}" type="presParOf" srcId="{3A3C9431-5B72-4FD3-9B99-9774F8C7BA6C}" destId="{63C6E861-CCF9-4923-BCC7-D8AE8240310A}" srcOrd="1" destOrd="0" presId="urn:microsoft.com/office/officeart/2018/5/layout/IconLeafLabelList"/>
-    <dgm:cxn modelId="{73DD66D9-6614-41A1-8EDE-D51E95CDED83}" type="presParOf" srcId="{3A3C9431-5B72-4FD3-9B99-9774F8C7BA6C}" destId="{BC8D8005-5109-42A3-9898-D9DFDFD950AE}" srcOrd="2" destOrd="0" presId="urn:microsoft.com/office/officeart/2018/5/layout/IconLeafLabelList"/>
-    <dgm:cxn modelId="{E3534068-4CC1-4C54-90F1-2810D5B6460F}" type="presParOf" srcId="{3A3C9431-5B72-4FD3-9B99-9774F8C7BA6C}" destId="{7EE269EF-7E38-4A21-98A9-338507085687}" srcOrd="3" destOrd="0" presId="urn:microsoft.com/office/officeart/2018/5/layout/IconLeafLabelList"/>
+    <dgm:cxn modelId="{AD8B8CE7-C20F-4334-ABEB-C7C624A1C5FA}" type="presOf" srcId="{1D88291D-2066-41AA-83F2-C95E9A97D00A}" destId="{7EE269EF-7E38-4A21-98A9-338507085687}" srcOrd="0" destOrd="0" presId="urn:microsoft.com/office/officeart/2018/5/layout/IconLeafLabelList"/>
+    <dgm:cxn modelId="{BB7B8AE9-5CCB-41B2-883C-86A8DB8EBCC8}" type="presOf" srcId="{DD844099-09D9-4176-9D09-04DC8634D869}" destId="{D8ADCAA9-FC51-4EF4-9FF7-67F32462255F}" srcOrd="0" destOrd="0" presId="urn:microsoft.com/office/officeart/2018/5/layout/IconLeafLabelList"/>
+    <dgm:cxn modelId="{04B0A999-B275-4B86-B776-BA5E5DB2BEF5}" type="presParOf" srcId="{FB41830B-D528-4EF1-992C-56941B20706C}" destId="{61A486D0-BD1D-43C9-8C0D-32381BAC4B0D}" srcOrd="0" destOrd="0" presId="urn:microsoft.com/office/officeart/2018/5/layout/IconLeafLabelList"/>
+    <dgm:cxn modelId="{5308D822-A628-4209-B733-BF9132780400}" type="presParOf" srcId="{61A486D0-BD1D-43C9-8C0D-32381BAC4B0D}" destId="{A366D388-5187-4B83-91E0-6E344AB43643}" srcOrd="0" destOrd="0" presId="urn:microsoft.com/office/officeart/2018/5/layout/IconLeafLabelList"/>
+    <dgm:cxn modelId="{B5DBEA96-5E9A-409A-B977-68839A7554DF}" type="presParOf" srcId="{61A486D0-BD1D-43C9-8C0D-32381BAC4B0D}" destId="{A51A27D5-074B-4463-AA5F-C91BAD0101FC}" srcOrd="1" destOrd="0" presId="urn:microsoft.com/office/officeart/2018/5/layout/IconLeafLabelList"/>
+    <dgm:cxn modelId="{6B1DC7B1-4C65-4BF7-8989-C56F2E0AE013}" type="presParOf" srcId="{61A486D0-BD1D-43C9-8C0D-32381BAC4B0D}" destId="{6B2853A1-4BF8-4E9F-B8E6-6704AEFC8C61}" srcOrd="2" destOrd="0" presId="urn:microsoft.com/office/officeart/2018/5/layout/IconLeafLabelList"/>
+    <dgm:cxn modelId="{BC85A9A9-C469-404A-87AE-4DA274453FDC}" type="presParOf" srcId="{61A486D0-BD1D-43C9-8C0D-32381BAC4B0D}" destId="{4B691EFD-B269-4CA7-932D-6797DB9C8247}" srcOrd="3" destOrd="0" presId="urn:microsoft.com/office/officeart/2018/5/layout/IconLeafLabelList"/>
+    <dgm:cxn modelId="{644D9D2B-9490-4FB8-AF34-BFAF0FBCD3B9}" type="presParOf" srcId="{FB41830B-D528-4EF1-992C-56941B20706C}" destId="{56A774B7-9CEF-4AB7-AEA5-3801362948B7}" srcOrd="1" destOrd="0" presId="urn:microsoft.com/office/officeart/2018/5/layout/IconLeafLabelList"/>
+    <dgm:cxn modelId="{2310D54A-F3E3-4706-A0B3-CCA4C81D7B45}" type="presParOf" srcId="{FB41830B-D528-4EF1-992C-56941B20706C}" destId="{7756E9F3-F9CD-4306-8BE5-744416E437A0}" srcOrd="2" destOrd="0" presId="urn:microsoft.com/office/officeart/2018/5/layout/IconLeafLabelList"/>
+    <dgm:cxn modelId="{4BD13A07-C840-4A05-9A7D-893DEF233798}" type="presParOf" srcId="{7756E9F3-F9CD-4306-8BE5-744416E437A0}" destId="{98EA8074-91BA-4F37-8400-281BAC8B85AC}" srcOrd="0" destOrd="0" presId="urn:microsoft.com/office/officeart/2018/5/layout/IconLeafLabelList"/>
+    <dgm:cxn modelId="{5C98E9F1-5731-412A-AACD-F026A31E0690}" type="presParOf" srcId="{7756E9F3-F9CD-4306-8BE5-744416E437A0}" destId="{BCC39ADA-0AE6-4A74-86AE-7B5DCFA5AF06}" srcOrd="1" destOrd="0" presId="urn:microsoft.com/office/officeart/2018/5/layout/IconLeafLabelList"/>
+    <dgm:cxn modelId="{F7114CB4-C5C9-4B66-8196-8F37C1453A35}" type="presParOf" srcId="{7756E9F3-F9CD-4306-8BE5-744416E437A0}" destId="{D40D94F4-905E-457A-A475-08862384F6D6}" srcOrd="2" destOrd="0" presId="urn:microsoft.com/office/officeart/2018/5/layout/IconLeafLabelList"/>
+    <dgm:cxn modelId="{733ADD85-34A8-4720-927C-C8305E5CE12E}" type="presParOf" srcId="{7756E9F3-F9CD-4306-8BE5-744416E437A0}" destId="{D8ADCAA9-FC51-4EF4-9FF7-67F32462255F}" srcOrd="3" destOrd="0" presId="urn:microsoft.com/office/officeart/2018/5/layout/IconLeafLabelList"/>
+    <dgm:cxn modelId="{4D496393-6A95-411C-B0CA-2D0CB7CB9D9A}" type="presParOf" srcId="{FB41830B-D528-4EF1-992C-56941B20706C}" destId="{3CB78F99-D930-4AE3-9678-60B8C8AEB5FE}" srcOrd="3" destOrd="0" presId="urn:microsoft.com/office/officeart/2018/5/layout/IconLeafLabelList"/>
+    <dgm:cxn modelId="{E72F0180-789E-4B62-9AFD-A0E26F705E4C}" type="presParOf" srcId="{FB41830B-D528-4EF1-992C-56941B20706C}" destId="{D78A3DBB-82E5-490C-B301-0D08000AC7A3}" srcOrd="4" destOrd="0" presId="urn:microsoft.com/office/officeart/2018/5/layout/IconLeafLabelList"/>
+    <dgm:cxn modelId="{AFB51A2E-4158-4B13-8BCA-E2D2FA6E08DB}" type="presParOf" srcId="{D78A3DBB-82E5-490C-B301-0D08000AC7A3}" destId="{7CE07CC9-08F1-4CF6-BE07-714FC2703C80}" srcOrd="0" destOrd="0" presId="urn:microsoft.com/office/officeart/2018/5/layout/IconLeafLabelList"/>
+    <dgm:cxn modelId="{528D86D6-F3D0-4873-967E-BAA7321A4BE4}" type="presParOf" srcId="{D78A3DBB-82E5-490C-B301-0D08000AC7A3}" destId="{703D2A3C-1CDD-46B0-8269-0384BEACC37F}" srcOrd="1" destOrd="0" presId="urn:microsoft.com/office/officeart/2018/5/layout/IconLeafLabelList"/>
+    <dgm:cxn modelId="{CA33DAFE-88C0-438D-8396-8C8443E1C0F8}" type="presParOf" srcId="{D78A3DBB-82E5-490C-B301-0D08000AC7A3}" destId="{603CB7F2-C4DB-4E4E-B86C-6F1C40BDC9E8}" srcOrd="2" destOrd="0" presId="urn:microsoft.com/office/officeart/2018/5/layout/IconLeafLabelList"/>
+    <dgm:cxn modelId="{BF93BCF0-49EF-4AE6-AA94-F416AA01068C}" type="presParOf" srcId="{D78A3DBB-82E5-490C-B301-0D08000AC7A3}" destId="{A2E01365-6E26-40CE-80C4-551C1E26459E}" srcOrd="3" destOrd="0" presId="urn:microsoft.com/office/officeart/2018/5/layout/IconLeafLabelList"/>
+    <dgm:cxn modelId="{3DA44515-7C17-428F-BD61-9631E67633FC}" type="presParOf" srcId="{FB41830B-D528-4EF1-992C-56941B20706C}" destId="{A6050820-2AE8-4C1E-8B45-06C1F9A7A36F}" srcOrd="5" destOrd="0" presId="urn:microsoft.com/office/officeart/2018/5/layout/IconLeafLabelList"/>
+    <dgm:cxn modelId="{710906B0-F142-4E2D-8FEF-7DE14B3358FE}" type="presParOf" srcId="{FB41830B-D528-4EF1-992C-56941B20706C}" destId="{FC8EC8C0-E71B-464F-922E-C5B89B1A8231}" srcOrd="6" destOrd="0" presId="urn:microsoft.com/office/officeart/2018/5/layout/IconLeafLabelList"/>
+    <dgm:cxn modelId="{50D1CB82-A52B-42EC-8EF2-08DF253D2B6D}" type="presParOf" srcId="{FC8EC8C0-E71B-464F-922E-C5B89B1A8231}" destId="{93511C22-D1BE-4E6A-A774-854639220357}" srcOrd="0" destOrd="0" presId="urn:microsoft.com/office/officeart/2018/5/layout/IconLeafLabelList"/>
+    <dgm:cxn modelId="{189F0537-5906-4D17-BD11-67D354044721}" type="presParOf" srcId="{FC8EC8C0-E71B-464F-922E-C5B89B1A8231}" destId="{E7C25ED2-8DE3-491B-9855-23F6F91ECE47}" srcOrd="1" destOrd="0" presId="urn:microsoft.com/office/officeart/2018/5/layout/IconLeafLabelList"/>
+    <dgm:cxn modelId="{B601130C-0A44-45D6-B738-314410F9DE4C}" type="presParOf" srcId="{FC8EC8C0-E71B-464F-922E-C5B89B1A8231}" destId="{AE279F2E-8592-4BD7-9CC6-4696C1198298}" srcOrd="2" destOrd="0" presId="urn:microsoft.com/office/officeart/2018/5/layout/IconLeafLabelList"/>
+    <dgm:cxn modelId="{E44CE9C3-34B5-4542-BA94-2EAB076253FC}" type="presParOf" srcId="{FC8EC8C0-E71B-464F-922E-C5B89B1A8231}" destId="{416B4E3C-E3B1-40FD-99B5-8458F3238C8A}" srcOrd="3" destOrd="0" presId="urn:microsoft.com/office/officeart/2018/5/layout/IconLeafLabelList"/>
+    <dgm:cxn modelId="{E215FAD4-EF92-48BE-809F-07781C0E2009}" type="presParOf" srcId="{FB41830B-D528-4EF1-992C-56941B20706C}" destId="{6FE06377-0D57-45A7-B6CD-8A7DD547A58E}" srcOrd="7" destOrd="0" presId="urn:microsoft.com/office/officeart/2018/5/layout/IconLeafLabelList"/>
+    <dgm:cxn modelId="{2E7F0B4F-E58A-4A18-9264-A9F6D0C94E7F}" type="presParOf" srcId="{FB41830B-D528-4EF1-992C-56941B20706C}" destId="{3A3C9431-5B72-4FD3-9B99-9774F8C7BA6C}" srcOrd="8" destOrd="0" presId="urn:microsoft.com/office/officeart/2018/5/layout/IconLeafLabelList"/>
+    <dgm:cxn modelId="{D68A2254-2CCA-426E-A35C-5711BEDA8987}" type="presParOf" srcId="{3A3C9431-5B72-4FD3-9B99-9774F8C7BA6C}" destId="{12F373DD-BC05-4BB2-82BA-547BFC3FF142}" srcOrd="0" destOrd="0" presId="urn:microsoft.com/office/officeart/2018/5/layout/IconLeafLabelList"/>
+    <dgm:cxn modelId="{1541AA7B-A46C-4C6A-B8F9-78C20A68FAA4}" type="presParOf" srcId="{3A3C9431-5B72-4FD3-9B99-9774F8C7BA6C}" destId="{63C6E861-CCF9-4923-BCC7-D8AE8240310A}" srcOrd="1" destOrd="0" presId="urn:microsoft.com/office/officeart/2018/5/layout/IconLeafLabelList"/>
+    <dgm:cxn modelId="{90285483-2150-44CC-A1B6-D17806F20291}" type="presParOf" srcId="{3A3C9431-5B72-4FD3-9B99-9774F8C7BA6C}" destId="{BC8D8005-5109-42A3-9898-D9DFDFD950AE}" srcOrd="2" destOrd="0" presId="urn:microsoft.com/office/officeart/2018/5/layout/IconLeafLabelList"/>
+    <dgm:cxn modelId="{E560CA20-9164-4EF5-BFAF-B0F3AEB5119A}" type="presParOf" srcId="{3A3C9431-5B72-4FD3-9B99-9774F8C7BA6C}" destId="{7EE269EF-7E38-4A21-98A9-338507085687}" srcOrd="3" destOrd="0" presId="urn:microsoft.com/office/officeart/2018/5/layout/IconLeafLabelList"/>
   </dgm:cxnLst>
   <dgm:bg/>
   <dgm:whole/>
@@ -4617,7 +4617,7 @@
       </dgm:t>
     </dgm:pt>
     <dgm:pt modelId="{F59C11C5-C8EA-4953-BDB5-CAF202EA9129}">
-      <dgm:prSet/>
+      <dgm:prSet custT="1"/>
       <dgm:spPr/>
       <dgm:t>
         <a:bodyPr/>
@@ -4629,7 +4629,7 @@
             </a:lnSpc>
           </a:pPr>
           <a:r>
-            <a:rPr lang="en-US" dirty="0"/>
+            <a:rPr lang="en-US" sz="1800" dirty="0"/>
             <a:t>Allow users to dynamically switch which dimensions or measures are displayed in visuals</a:t>
           </a:r>
         </a:p>
@@ -4658,7 +4658,7 @@
       </dgm:t>
     </dgm:pt>
     <dgm:pt modelId="{3F9C9AF5-D01A-412C-9F02-87E9003DB3E2}">
-      <dgm:prSet phldrT="[Text]"/>
+      <dgm:prSet phldrT="[Text]" custT="1"/>
       <dgm:spPr/>
       <dgm:t>
         <a:bodyPr/>
@@ -4670,7 +4670,7 @@
             </a:lnSpc>
           </a:pPr>
           <a:r>
-            <a:rPr lang="en-US" dirty="0"/>
+            <a:rPr lang="en-US" sz="1800" dirty="0"/>
             <a:t>Allow users to group measures so they can toggle displayed columns</a:t>
           </a:r>
         </a:p>
@@ -4712,7 +4712,7 @@
       <dgm:spPr/>
     </dgm:pt>
     <dgm:pt modelId="{F8CB7DB8-1A1C-48BF-968B-A989A0330683}" type="pres">
-      <dgm:prSet presAssocID="{F59C11C5-C8EA-4953-BDB5-CAF202EA9129}" presName="iconRect" presStyleLbl="node1" presStyleIdx="0" presStyleCnt="2"/>
+      <dgm:prSet presAssocID="{F59C11C5-C8EA-4953-BDB5-CAF202EA9129}" presName="iconRect" presStyleLbl="node1" presStyleIdx="0" presStyleCnt="2" custScaleX="138759" custScaleY="138759"/>
       <dgm:spPr>
         <a:blipFill>
           <a:blip xmlns:r="http://schemas.openxmlformats.org/officeDocument/2006/relationships" r:embed="rId1"/>
@@ -4731,7 +4731,7 @@
       <dgm:spPr/>
     </dgm:pt>
     <dgm:pt modelId="{5A9515F9-AB49-4937-B666-0A4950981ED7}" type="pres">
-      <dgm:prSet presAssocID="{F59C11C5-C8EA-4953-BDB5-CAF202EA9129}" presName="textRect" presStyleLbl="revTx" presStyleIdx="0" presStyleCnt="2">
+      <dgm:prSet presAssocID="{F59C11C5-C8EA-4953-BDB5-CAF202EA9129}" presName="textRect" presStyleLbl="revTx" presStyleIdx="0" presStyleCnt="2" custScaleX="118533">
         <dgm:presLayoutVars>
           <dgm:chMax val="1"/>
           <dgm:chPref val="1"/>
@@ -4748,7 +4748,7 @@
       <dgm:spPr/>
     </dgm:pt>
     <dgm:pt modelId="{F96959D0-7EE5-48BB-A1E2-BB9A302BA209}" type="pres">
-      <dgm:prSet presAssocID="{3F9C9AF5-D01A-412C-9F02-87E9003DB3E2}" presName="iconRect" presStyleLbl="node1" presStyleIdx="1" presStyleCnt="2"/>
+      <dgm:prSet presAssocID="{3F9C9AF5-D01A-412C-9F02-87E9003DB3E2}" presName="iconRect" presStyleLbl="node1" presStyleIdx="1" presStyleCnt="2" custScaleX="138759" custScaleY="138759"/>
       <dgm:spPr>
         <a:blipFill>
           <a:blip xmlns:r="http://schemas.openxmlformats.org/officeDocument/2006/relationships">
@@ -4775,7 +4775,7 @@
       <dgm:spPr/>
     </dgm:pt>
     <dgm:pt modelId="{A8BFB3C8-08A9-4E31-BB31-3861B45454B8}" type="pres">
-      <dgm:prSet presAssocID="{3F9C9AF5-D01A-412C-9F02-87E9003DB3E2}" presName="textRect" presStyleLbl="revTx" presStyleIdx="1" presStyleCnt="2">
+      <dgm:prSet presAssocID="{3F9C9AF5-D01A-412C-9F02-87E9003DB3E2}" presName="textRect" presStyleLbl="revTx" presStyleIdx="1" presStyleCnt="2" custScaleX="120734">
         <dgm:presLayoutVars>
           <dgm:chMax val="1"/>
           <dgm:chPref val="1"/>
@@ -5940,7 +5940,7 @@
         <a:ext cx="1800000" cy="720000"/>
       </dsp:txXfrm>
     </dsp:sp>
-    <dsp:sp modelId="{93511C22-D1BE-4E6A-A774-854639220357}">
+    <dsp:sp modelId="{7CE07CC9-08F1-4CF6-BE07-714FC2703C80}">
       <dsp:nvSpPr>
         <dsp:cNvPr id="0" name=""/>
         <dsp:cNvSpPr/>
@@ -5982,7 +5982,7 @@
         <a:fontRef idx="minor"/>
       </dsp:style>
     </dsp:sp>
-    <dsp:sp modelId="{E7C25ED2-8DE3-491B-9855-23F6F91ECE47}">
+    <dsp:sp modelId="{703D2A3C-1CDD-46B0-8269-0384BEACC37F}">
       <dsp:nvSpPr>
         <dsp:cNvPr id="0" name=""/>
         <dsp:cNvSpPr/>
@@ -6032,7 +6032,7 @@
         </a:fontRef>
       </dsp:style>
     </dsp:sp>
-    <dsp:sp modelId="{416B4E3C-E3B1-40FD-99B5-8458F3238C8A}">
+    <dsp:sp modelId="{A2E01365-6E26-40CE-80C4-551C1E26459E}">
       <dsp:nvSpPr>
         <dsp:cNvPr id="0" name=""/>
         <dsp:cNvSpPr/>
@@ -6084,7 +6084,7 @@
           </a:pPr>
           <a:r>
             <a:rPr lang="en-US" sz="1700" b="1" kern="1200" dirty="0"/>
-            <a:t>Guided storytelling</a:t>
+            <a:t>Customized views</a:t>
           </a:r>
           <a:endParaRPr lang="en-US" sz="1700" kern="1200" dirty="0"/>
         </a:p>
@@ -6094,7 +6094,7 @@
         <a:ext cx="1800000" cy="720000"/>
       </dsp:txXfrm>
     </dsp:sp>
-    <dsp:sp modelId="{7CE07CC9-08F1-4CF6-BE07-714FC2703C80}">
+    <dsp:sp modelId="{93511C22-D1BE-4E6A-A774-854639220357}">
       <dsp:nvSpPr>
         <dsp:cNvPr id="0" name=""/>
         <dsp:cNvSpPr/>
@@ -6136,7 +6136,7 @@
         <a:fontRef idx="minor"/>
       </dsp:style>
     </dsp:sp>
-    <dsp:sp modelId="{703D2A3C-1CDD-46B0-8269-0384BEACC37F}">
+    <dsp:sp modelId="{E7C25ED2-8DE3-491B-9855-23F6F91ECE47}">
       <dsp:nvSpPr>
         <dsp:cNvPr id="0" name=""/>
         <dsp:cNvSpPr/>
@@ -6186,7 +6186,7 @@
         </a:fontRef>
       </dsp:style>
     </dsp:sp>
-    <dsp:sp modelId="{A2E01365-6E26-40CE-80C4-551C1E26459E}">
+    <dsp:sp modelId="{416B4E3C-E3B1-40FD-99B5-8458F3238C8A}">
       <dsp:nvSpPr>
         <dsp:cNvPr id="0" name=""/>
         <dsp:cNvSpPr/>
@@ -6238,7 +6238,7 @@
           </a:pPr>
           <a:r>
             <a:rPr lang="en-US" sz="1700" b="1" kern="1200" dirty="0"/>
-            <a:t>Customized views</a:t>
+            <a:t>Guided storytelling</a:t>
           </a:r>
           <a:endParaRPr lang="en-US" sz="1700" kern="1200" dirty="0"/>
         </a:p>
@@ -6421,8 +6421,8 @@
       </dsp:nvSpPr>
       <dsp:spPr>
         <a:xfrm>
-          <a:off x="2586000" y="776582"/>
-          <a:ext cx="1944000" cy="1944000"/>
+          <a:off x="1840424" y="596650"/>
+          <a:ext cx="2648302" cy="2648302"/>
         </a:xfrm>
         <a:prstGeom prst="rect">
           <a:avLst/>
@@ -6463,8 +6463,8 @@
       </dsp:nvSpPr>
       <dsp:spPr>
         <a:xfrm>
-          <a:off x="1398000" y="3190784"/>
-          <a:ext cx="4320000" cy="720000"/>
+          <a:off x="650934" y="3343717"/>
+          <a:ext cx="5027280" cy="746999"/>
         </a:xfrm>
         <a:prstGeom prst="rect">
           <a:avLst/>
@@ -6493,7 +6493,7 @@
         </a:bodyPr>
         <a:lstStyle/>
         <a:p>
-          <a:pPr marL="0" lvl="0" indent="0" algn="ctr" defTabSz="711200">
+          <a:pPr marL="0" lvl="0" indent="0" algn="ctr" defTabSz="800100">
             <a:lnSpc>
               <a:spcPct val="100000"/>
             </a:lnSpc>
@@ -6506,14 +6506,14 @@
             <a:buNone/>
           </a:pPr>
           <a:r>
-            <a:rPr lang="en-US" sz="1600" kern="1200" dirty="0"/>
+            <a:rPr lang="en-US" sz="1800" kern="1200" dirty="0"/>
             <a:t>Allow users to dynamically switch which dimensions or measures are displayed in visuals</a:t>
           </a:r>
         </a:p>
       </dsp:txBody>
       <dsp:txXfrm>
-        <a:off x="1398000" y="3190784"/>
-        <a:ext cx="4320000" cy="720000"/>
+        <a:off x="650934" y="3343717"/>
+        <a:ext cx="5027280" cy="746999"/>
       </dsp:txXfrm>
     </dsp:sp>
     <dsp:sp modelId="{F96959D0-7EE5-48BB-A1E2-BB9A302BA209}">
@@ -6523,8 +6523,8 @@
       </dsp:nvSpPr>
       <dsp:spPr>
         <a:xfrm>
-          <a:off x="7662000" y="776582"/>
-          <a:ext cx="1944000" cy="1944000"/>
+          <a:off x="7656598" y="596650"/>
+          <a:ext cx="2648302" cy="2648302"/>
         </a:xfrm>
         <a:prstGeom prst="rect">
           <a:avLst/>
@@ -6579,8 +6579,8 @@
       </dsp:nvSpPr>
       <dsp:spPr>
         <a:xfrm>
-          <a:off x="6474000" y="3190784"/>
-          <a:ext cx="4320000" cy="720000"/>
+          <a:off x="6420434" y="3343717"/>
+          <a:ext cx="5120630" cy="746999"/>
         </a:xfrm>
         <a:prstGeom prst="rect">
           <a:avLst/>
@@ -6609,7 +6609,7 @@
         </a:bodyPr>
         <a:lstStyle/>
         <a:p>
-          <a:pPr marL="0" lvl="0" indent="0" algn="ctr" defTabSz="711200">
+          <a:pPr marL="0" lvl="0" indent="0" algn="ctr" defTabSz="800100">
             <a:lnSpc>
               <a:spcPct val="100000"/>
             </a:lnSpc>
@@ -6622,14 +6622,14 @@
             <a:buNone/>
           </a:pPr>
           <a:r>
-            <a:rPr lang="en-US" sz="1600" kern="1200" dirty="0"/>
+            <a:rPr lang="en-US" sz="1800" kern="1200" dirty="0"/>
             <a:t>Allow users to group measures so they can toggle displayed columns</a:t>
           </a:r>
         </a:p>
       </dsp:txBody>
       <dsp:txXfrm>
-        <a:off x="6474000" y="3190784"/>
-        <a:ext cx="4320000" cy="720000"/>
+        <a:off x="6420434" y="3343717"/>
+        <a:ext cx="5120630" cy="746999"/>
       </dsp:txXfrm>
     </dsp:sp>
   </dsp:spTree>
@@ -12478,7 +12478,7 @@
           <a:p>
             <a:fld id="{A404F555-6570-4A15-ABC4-1745CA5C4DCB}" type="datetimeFigureOut">
               <a:rPr lang="en-US" smtClean="0"/>
-              <a:t>6/5/2026</a:t>
+              <a:t>6/11/2026</a:t>
             </a:fld>
             <a:endParaRPr lang="en-US"/>
           </a:p>
@@ -13780,7 +13780,7 @@
           <a:p>
             <a:fld id="{EE7FC4FF-A5B5-49B5-AF2E-5BC38B72E229}" type="datetimeFigureOut">
               <a:rPr lang="en-US" smtClean="0"/>
-              <a:t>6/5/2026</a:t>
+              <a:t>6/11/2026</a:t>
             </a:fld>
             <a:endParaRPr lang="en-US"/>
           </a:p>
@@ -13978,7 +13978,7 @@
           <a:p>
             <a:fld id="{EE7FC4FF-A5B5-49B5-AF2E-5BC38B72E229}" type="datetimeFigureOut">
               <a:rPr lang="en-US" smtClean="0"/>
-              <a:t>6/5/2026</a:t>
+              <a:t>6/11/2026</a:t>
             </a:fld>
             <a:endParaRPr lang="en-US"/>
           </a:p>
@@ -14186,7 +14186,7 @@
           <a:p>
             <a:fld id="{EE7FC4FF-A5B5-49B5-AF2E-5BC38B72E229}" type="datetimeFigureOut">
               <a:rPr lang="en-US" smtClean="0"/>
-              <a:t>6/5/2026</a:t>
+              <a:t>6/11/2026</a:t>
             </a:fld>
             <a:endParaRPr lang="en-US"/>
           </a:p>
@@ -14384,7 +14384,7 @@
           <a:p>
             <a:fld id="{EE7FC4FF-A5B5-49B5-AF2E-5BC38B72E229}" type="datetimeFigureOut">
               <a:rPr lang="en-US" smtClean="0"/>
-              <a:t>6/5/2026</a:t>
+              <a:t>6/11/2026</a:t>
             </a:fld>
             <a:endParaRPr lang="en-US"/>
           </a:p>
@@ -14659,7 +14659,7 @@
           <a:p>
             <a:fld id="{EE7FC4FF-A5B5-49B5-AF2E-5BC38B72E229}" type="datetimeFigureOut">
               <a:rPr lang="en-US" smtClean="0"/>
-              <a:t>6/5/2026</a:t>
+              <a:t>6/11/2026</a:t>
             </a:fld>
             <a:endParaRPr lang="en-US"/>
           </a:p>
@@ -14924,7 +14924,7 @@
           <a:p>
             <a:fld id="{EE7FC4FF-A5B5-49B5-AF2E-5BC38B72E229}" type="datetimeFigureOut">
               <a:rPr lang="en-US" smtClean="0"/>
-              <a:t>6/5/2026</a:t>
+              <a:t>6/11/2026</a:t>
             </a:fld>
             <a:endParaRPr lang="en-US"/>
           </a:p>
@@ -15336,7 +15336,7 @@
           <a:p>
             <a:fld id="{EE7FC4FF-A5B5-49B5-AF2E-5BC38B72E229}" type="datetimeFigureOut">
               <a:rPr lang="en-US" smtClean="0"/>
-              <a:t>6/5/2026</a:t>
+              <a:t>6/11/2026</a:t>
             </a:fld>
             <a:endParaRPr lang="en-US"/>
           </a:p>
@@ -15477,7 +15477,7 @@
           <a:p>
             <a:fld id="{EE7FC4FF-A5B5-49B5-AF2E-5BC38B72E229}" type="datetimeFigureOut">
               <a:rPr lang="en-US" smtClean="0"/>
-              <a:t>6/5/2026</a:t>
+              <a:t>6/11/2026</a:t>
             </a:fld>
             <a:endParaRPr lang="en-US"/>
           </a:p>
@@ -15590,7 +15590,7 @@
           <a:p>
             <a:fld id="{EE7FC4FF-A5B5-49B5-AF2E-5BC38B72E229}" type="datetimeFigureOut">
               <a:rPr lang="en-US" smtClean="0"/>
-              <a:t>6/5/2026</a:t>
+              <a:t>6/11/2026</a:t>
             </a:fld>
             <a:endParaRPr lang="en-US"/>
           </a:p>
@@ -15901,7 +15901,7 @@
           <a:p>
             <a:fld id="{EE7FC4FF-A5B5-49B5-AF2E-5BC38B72E229}" type="datetimeFigureOut">
               <a:rPr lang="en-US" smtClean="0"/>
-              <a:t>6/5/2026</a:t>
+              <a:t>6/11/2026</a:t>
             </a:fld>
             <a:endParaRPr lang="en-US"/>
           </a:p>
@@ -16189,7 +16189,7 @@
           <a:p>
             <a:fld id="{EE7FC4FF-A5B5-49B5-AF2E-5BC38B72E229}" type="datetimeFigureOut">
               <a:rPr lang="en-US" smtClean="0"/>
-              <a:t>6/5/2026</a:t>
+              <a:t>6/11/2026</a:t>
             </a:fld>
             <a:endParaRPr lang="en-US"/>
           </a:p>
@@ -16430,7 +16430,7 @@
           <a:p>
             <a:fld id="{EE7FC4FF-A5B5-49B5-AF2E-5BC38B72E229}" type="datetimeFigureOut">
               <a:rPr lang="en-US" smtClean="0"/>
-              <a:t>6/5/2026</a:t>
+              <a:t>6/11/2026</a:t>
             </a:fld>
             <a:endParaRPr lang="en-US"/>
           </a:p>
@@ -17452,10 +17452,10 @@
       </p:sp>
       <p:pic>
         <p:nvPicPr>
-          <p:cNvPr id="6" name="Picture 5" descr="A qr code with a white background&#10;&#10;AI-generated content may be incorrect.">
+          <p:cNvPr id="5" name="Picture 4">
             <a:extLst>
               <a:ext uri="{FF2B5EF4-FFF2-40B4-BE49-F238E27FC236}">
-                <a16:creationId xmlns:a16="http://schemas.microsoft.com/office/drawing/2014/main" id="{4C76F6F5-61D5-66D0-D351-A2F48C213A4C}"/>
+                <a16:creationId xmlns:a16="http://schemas.microsoft.com/office/drawing/2014/main" id="{6C545E96-B276-5884-C589-310306BBBD67}"/>
               </a:ext>
             </a:extLst>
           </p:cNvPr>
@@ -17478,8 +17478,8 @@
         </p:blipFill>
         <p:spPr>
           <a:xfrm>
-            <a:off x="9875371" y="4916574"/>
-            <a:ext cx="1931894" cy="1931894"/>
+            <a:off x="10622795" y="5280994"/>
+            <a:ext cx="1467675" cy="1467675"/>
           </a:xfrm>
           <a:prstGeom prst="rect">
             <a:avLst/>
@@ -19367,7 +19367,7 @@
           <p:nvPr>
             <p:extLst>
               <p:ext uri="{D42A27DB-BD31-4B8C-83A1-F6EECF244321}">
-                <p14:modId xmlns:p14="http://schemas.microsoft.com/office/powerpoint/2010/main" val="730595657"/>
+                <p14:modId xmlns:p14="http://schemas.microsoft.com/office/powerpoint/2010/main" val="3141565510"/>
               </p:ext>
             </p:extLst>
           </p:nvPr>
@@ -20606,7 +20606,7 @@
           <p:nvPr>
             <p:extLst>
               <p:ext uri="{D42A27DB-BD31-4B8C-83A1-F6EECF244321}">
-                <p14:modId xmlns:p14="http://schemas.microsoft.com/office/powerpoint/2010/main" val="188205978"/>
+                <p14:modId xmlns:p14="http://schemas.microsoft.com/office/powerpoint/2010/main" val="1846269447"/>
               </p:ext>
             </p:extLst>
           </p:nvPr>
@@ -21811,17 +21811,17 @@
             <a:pPr algn="ctr"/>
             <a:r>
               <a:rPr lang="en-US" dirty="0"/>
-              <a:t>Portfolio/GitHub Link</a:t>
+              <a:t>GitHub Link</a:t>
             </a:r>
           </a:p>
         </p:txBody>
       </p:sp>
       <p:pic>
         <p:nvPicPr>
-          <p:cNvPr id="11" name="Picture 10" descr="A qr code with a white background&#10;&#10;AI-generated content may be incorrect.">
+          <p:cNvPr id="7" name="Picture 6">
             <a:extLst>
               <a:ext uri="{FF2B5EF4-FFF2-40B4-BE49-F238E27FC236}">
-                <a16:creationId xmlns:a16="http://schemas.microsoft.com/office/drawing/2014/main" id="{37711FD9-AF68-F0C3-107A-3E9E64EC5334}"/>
+                <a16:creationId xmlns:a16="http://schemas.microsoft.com/office/drawing/2014/main" id="{2FF99EDB-064C-89FE-8A83-0DC6DDF520A1}"/>
               </a:ext>
             </a:extLst>
           </p:cNvPr>
@@ -21844,7 +21844,7 @@
         </p:blipFill>
         <p:spPr>
           <a:xfrm>
-            <a:off x="4836407" y="2208445"/>
+            <a:off x="8520684" y="2208445"/>
             <a:ext cx="2880360" cy="2880360"/>
           </a:xfrm>
           <a:prstGeom prst="rect">
@@ -21854,10 +21854,10 @@
       </p:pic>
       <p:pic>
         <p:nvPicPr>
-          <p:cNvPr id="7" name="Picture 6">
+          <p:cNvPr id="3" name="Picture 2">
             <a:extLst>
               <a:ext uri="{FF2B5EF4-FFF2-40B4-BE49-F238E27FC236}">
-                <a16:creationId xmlns:a16="http://schemas.microsoft.com/office/drawing/2014/main" id="{2FF99EDB-064C-89FE-8A83-0DC6DDF520A1}"/>
+                <a16:creationId xmlns:a16="http://schemas.microsoft.com/office/drawing/2014/main" id="{97F71FEA-B579-B7E0-8442-C9D67C23B196}"/>
               </a:ext>
             </a:extLst>
           </p:cNvPr>
@@ -21880,7 +21880,7 @@
         </p:blipFill>
         <p:spPr>
           <a:xfrm>
-            <a:off x="8520684" y="2208445"/>
+            <a:off x="4841743" y="2280603"/>
             <a:ext cx="2880360" cy="2880360"/>
           </a:xfrm>
           <a:prstGeom prst="rect">

</xml_diff>